<commit_message>
Update team founder name to Sumera Shar
</commit_message>
<xml_diff>
--- a/PathPilot_Presentation.pptx
+++ b/PathPilot_Presentation.pptx
@@ -3383,7 +3383,7 @@
               </a:defRPr>
             </a:pPr>
             <a:r>
-              <a:t>👩‍💻 Sobia Sattar (AI Systems Lead)   •   👨‍💻 Muhammad Hassan (Data Systems Lead)   •   👩‍🎨 Sumra Shar (Creative Product Lead)</a:t>
+              <a:t>👩‍💻 Sobia Sattar (AI Systems Lead)   •   👨‍💻 Muhammad Hassan (Data Systems Lead)   •   👩‍🎨 Sumera Shar (Creative Product Lead)</a:t>
             </a:r>
           </a:p>
           <a:p>
@@ -5419,7 +5419,7 @@
               </a:defRPr>
             </a:pPr>
             <a:r>
-              <a:t>👩‍🎨 Sumra Shar</a:t>
+              <a:t>👩‍🎨 Sumera Shar</a:t>
             </a:r>
           </a:p>
           <a:p>
@@ -5456,7 +5456,7 @@
               </a:defRPr>
             </a:pPr>
             <a:r>
-              <a:t>"Believes learning tools should spark joy. Sumra crafted the signature Ronas IT pastel design system, Pip the cute mascot, and fluid animations that make planning feel playful."</a:t>
+              <a:t>"Believes learning tools should spark joy. Sumera crafted the signature Ronas IT pastel design system, Pip the cute mascot, and fluid animations that make planning feel playful."</a:t>
             </a:r>
           </a:p>
         </p:txBody>

</xml_diff>